<commit_message>
updated evaluation with non existing recipe names and evaluation
</commit_message>
<xml_diff>
--- a/ppt/craveitsearchitcookit_presentation.pptx
+++ b/ppt/craveitsearchitcookit_presentation.pptx
@@ -10,6 +10,7 @@
     <p:sldId id="258" r:id="rId4"/>
     <p:sldId id="259" r:id="rId5"/>
     <p:sldId id="260" r:id="rId6"/>
+    <p:sldId id="265" r:id="rId16"/>
     <p:sldId id="261" r:id="rId7"/>
     <p:sldId id="262" r:id="rId8"/>
     <p:sldId id="263" r:id="rId9"/>
@@ -225,7 +226,7 @@
               <c:strCache>
                 <c:ptCount val="1"/>
                 <c:pt idx="0">
-                  <c:v>Final (after prompt + harness fixes)</c:v>
+                  <c:v>Final (30-case run)</c:v>
                 </c:pt>
               </c:strCache>
             </c:strRef>
@@ -290,16 +291,16 @@
                 <c:formatCode>General</c:formatCode>
                 <c:ptCount val="4"/>
                 <c:pt idx="0">
-                  <c:v>4.6</c:v>
+                  <c:v>4.93</c:v>
                 </c:pt>
                 <c:pt idx="1">
-                  <c:v>4.56</c:v>
+                  <c:v>5</c:v>
                 </c:pt>
                 <c:pt idx="2">
-                  <c:v>3.8</c:v>
+                  <c:v>3.35</c:v>
                 </c:pt>
                 <c:pt idx="3">
-                  <c:v>4.6</c:v>
+                  <c:v>4.65</c:v>
                 </c:pt>
               </c:numCache>
             </c:numRef>
@@ -2151,6 +2152,731 @@
 </p:sld>
 </file>
 
+<file path=ppt/slides/slide10.xml><?xml version="1.0" encoding="utf-8"?>
+<p:sld xmlns:a="http://schemas.openxmlformats.org/drawingml/2006/main" xmlns:r="http://schemas.openxmlformats.org/officeDocument/2006/relationships" xmlns:p="http://schemas.openxmlformats.org/presentationml/2006/main">
+  <p:cSld name="Slide 5">
+    <p:bg>
+      <p:bgPr>
+        <a:solidFill>
+          <a:srgbClr val="FAF6F0"/>
+        </a:solidFill>
+      </p:bgPr>
+    </p:bg>
+    <p:spTree>
+      <p:nvGrpSpPr>
+        <p:cNvPr id="1" name=""/>
+        <p:cNvGrpSpPr/>
+        <p:nvPr/>
+      </p:nvGrpSpPr>
+      <p:grpSpPr>
+        <a:xfrm>
+          <a:off x="0" y="0"/>
+          <a:ext cx="0" cy="0"/>
+          <a:chOff x="0" y="0"/>
+          <a:chExt cx="0" cy="0"/>
+        </a:xfrm>
+      </p:grpSpPr>
+      <p:sp>
+        <p:nvSpPr>
+          <p:cNvPr id="2" name="Text 0"/>
+          <p:cNvSpPr txBox="1"/>
+          <p:nvPr/>
+        </p:nvSpPr>
+        <p:spPr>
+          <a:xfrm>
+            <a:off x="457200" y="365760"/>
+            <a:ext cx="8229600" cy="548640"/>
+          </a:xfrm>
+          <a:prstGeom prst="rect">
+            <a:avLst/>
+          </a:prstGeom>
+          <a:noFill/>
+          <a:ln/>
+        </p:spPr>
+        <p:txBody>
+          <a:bodyPr wrap="square" lIns="0" tIns="0" rIns="0" bIns="0" rtlCol="0" anchor="ctr"/>
+          <a:lstStyle/>
+          <a:p>
+            <a:pPr indent="0" marL="0">
+              <a:buNone/>
+            </a:pPr>
+            <a:r>
+              <a:rPr lang="en-US" sz="2600" b="1" dirty="0">
+                <a:solidFill>
+                  <a:srgbClr val="2A1912"/>
+                </a:solidFill>
+                <a:latin typeface="Georgia" pitchFamily="34" charset="0"/>
+                <a:ea typeface="Georgia" pitchFamily="34" charset="-122"/>
+                <a:cs typeface="Georgia" pitchFamily="34" charset="-120"/>
+              </a:rPr>
+              <a:t>Evaluation Dataset: 30 Cases</a:t>
+            </a:r>
+            <a:endParaRPr lang="en-US" sz="2600" dirty="0"/>
+          </a:p>
+        </p:txBody>
+      </p:sp>
+      <p:sp>
+        <p:nvSpPr>
+          <p:cNvPr id="3" name="Text 1"/>
+          <p:cNvSpPr txBox="1"/>
+          <p:nvPr/>
+        </p:nvSpPr>
+        <p:spPr>
+          <a:xfrm>
+            <a:off x="457200" y="960120"/>
+            <a:ext cx="8229600" cy="457200"/>
+          </a:xfrm>
+          <a:prstGeom prst="rect">
+            <a:avLst/>
+          </a:prstGeom>
+          <a:noFill/>
+          <a:ln/>
+        </p:spPr>
+        <p:txBody>
+          <a:bodyPr wrap="square" lIns="0" tIns="0" rIns="0" bIns="0" rtlCol="0" anchor="t"/>
+          <a:lstStyle/>
+          <a:p>
+            <a:pPr indent="0" marL="0">
+              <a:buNone/>
+            </a:pPr>
+            <a:r>
+              <a:rPr lang="en-US" sz="1200" i="1" dirty="0">
+                <a:solidFill>
+                  <a:srgbClr val="6B5E57"/>
+                </a:solidFill>
+                <a:latin typeface="Calibri" pitchFamily="34" charset="0"/>
+                <a:ea typeface="Calibri" pitchFamily="34" charset="-122"/>
+                <a:cs typeface="Calibri" pitchFamily="34" charset="-120"/>
+              </a:rPr>
+              <a:t>Extended from 25 to 30 queries to test refusal and near-miss behaviour, not just easy hits.</a:t>
+            </a:r>
+            <a:endParaRPr lang="en-US" sz="1200" dirty="0"/>
+          </a:p>
+        </p:txBody>
+      </p:sp>
+      <p:sp>
+        <p:nvSpPr>
+          <p:cNvPr id="4" name="Shape 2"/>
+          <p:cNvSpPr/>
+          <p:nvPr/>
+        </p:nvSpPr>
+        <p:spPr>
+          <a:xfrm>
+            <a:off x="411480" y="1645920"/>
+            <a:ext cx="1965960" cy="1828800"/>
+          </a:xfrm>
+          <a:prstGeom prst="roundRect">
+            <a:avLst>
+              <a:gd name="adj" fmla="val 3000"/>
+            </a:avLst>
+          </a:prstGeom>
+          <a:solidFill>
+            <a:srgbClr val="8B3A2F"/>
+          </a:solidFill>
+          <a:ln/>
+        </p:spPr>
+      </p:sp>
+      <p:sp>
+        <p:nvSpPr>
+          <p:cNvPr id="5" name="Shape 3"/>
+          <p:cNvSpPr/>
+          <p:nvPr/>
+        </p:nvSpPr>
+        <p:spPr>
+          <a:xfrm>
+            <a:off x="1124712" y="1783080"/>
+            <a:ext cx="502920" cy="502920"/>
+          </a:xfrm>
+          <a:prstGeom prst="ellipse">
+            <a:avLst/>
+          </a:prstGeom>
+          <a:solidFill>
+            <a:srgbClr val="6B2A22"/>
+          </a:solidFill>
+          <a:ln/>
+        </p:spPr>
+      </p:sp>
+      <p:pic>
+        <p:nvPicPr>
+          <p:cNvPr id="6" name="Image 0" descr="preencoded.png">    </p:cNvPr>
+          <p:cNvPicPr>
+            <a:picLocks noChangeAspect="1"/>
+          </p:cNvPicPr>
+          <p:nvPr/>
+        </p:nvPicPr>
+        <p:blipFill>
+          <a:blip r:embed="rId1"/>
+          <a:stretch>
+            <a:fillRect/>
+          </a:stretch>
+        </p:blipFill>
+        <p:spPr>
+          <a:xfrm>
+            <a:off x="1237869" y="1896237"/>
+            <a:ext cx="276606" cy="276606"/>
+          </a:xfrm>
+          <a:prstGeom prst="rect">
+            <a:avLst/>
+          </a:prstGeom>
+        </p:spPr>
+      </p:pic>
+      <p:sp>
+        <p:nvSpPr>
+          <p:cNvPr id="7" name="Text 4"/>
+          <p:cNvSpPr txBox="1"/>
+          <p:nvPr/>
+        </p:nvSpPr>
+        <p:spPr>
+          <a:xfrm>
+            <a:off x="502920" y="2423160"/>
+            <a:ext cx="1783080" cy="274320"/>
+          </a:xfrm>
+          <a:prstGeom prst="rect">
+            <a:avLst/>
+          </a:prstGeom>
+          <a:noFill/>
+          <a:ln/>
+        </p:spPr>
+        <p:txBody>
+          <a:bodyPr wrap="square" lIns="0" tIns="0" rIns="0" bIns="0" rtlCol="0" anchor="t"/>
+          <a:lstStyle/>
+          <a:p>
+            <a:pPr algn="ctr" indent="0" marL="0">
+              <a:buNone/>
+            </a:pPr>
+            <a:r>
+              <a:rPr lang="en-US" sz="1150" b="1" dirty="0">
+                <a:solidFill>
+                  <a:srgbClr val="FFFFFF"/>
+                </a:solidFill>
+                <a:latin typeface="Calibri" pitchFamily="34" charset="0"/>
+                <a:ea typeface="Calibri" pitchFamily="34" charset="-122"/>
+                <a:cs typeface="Calibri" pitchFamily="34" charset="-120"/>
+              </a:rPr>
+              <a:t>25 Baseline</a:t>
+            </a:r>
+            <a:endParaRPr lang="en-US" sz="1150" dirty="0"/>
+          </a:p>
+        </p:txBody>
+      </p:sp>
+      <p:sp>
+        <p:nvSpPr>
+          <p:cNvPr id="8" name="Text 5"/>
+          <p:cNvSpPr txBox="1"/>
+          <p:nvPr/>
+        </p:nvSpPr>
+        <p:spPr>
+          <a:xfrm>
+            <a:off x="548640" y="2743200"/>
+            <a:ext cx="1691640" cy="731520"/>
+          </a:xfrm>
+          <a:prstGeom prst="rect">
+            <a:avLst/>
+          </a:prstGeom>
+          <a:noFill/>
+          <a:ln/>
+        </p:spPr>
+        <p:txBody>
+          <a:bodyPr wrap="square" lIns="0" tIns="0" rIns="0" bIns="0" rtlCol="0" anchor="t"/>
+          <a:lstStyle/>
+          <a:p>
+            <a:pPr algn="ctr" indent="0" marL="0">
+              <a:buNone/>
+            </a:pPr>
+            <a:r>
+              <a:rPr lang="en-US" sz="850" dirty="0">
+                <a:solidFill>
+                  <a:srgbClr val="E8C29C"/>
+                </a:solidFill>
+                <a:latin typeface="Calibri" pitchFamily="34" charset="0"/>
+                <a:ea typeface="Calibri" pitchFamily="34" charset="-122"/>
+                <a:cs typeface="Calibri" pitchFamily="34" charset="-120"/>
+              </a:rPr>
+              <a:t>Dishes present in the corpus, incl. 5 non-English queries (Hindi, French, Spanish, Russian, Chinese).</a:t>
+            </a:r>
+            <a:endParaRPr lang="en-US" sz="850" dirty="0"/>
+          </a:p>
+        </p:txBody>
+      </p:sp>
+      <p:sp>
+        <p:nvSpPr>
+          <p:cNvPr id="9" name="Shape 6"/>
+          <p:cNvSpPr/>
+          <p:nvPr/>
+        </p:nvSpPr>
+        <p:spPr>
+          <a:xfrm>
+            <a:off x="2514600" y="1645920"/>
+            <a:ext cx="1965960" cy="1828800"/>
+          </a:xfrm>
+          <a:prstGeom prst="roundRect">
+            <a:avLst>
+              <a:gd name="adj" fmla="val 3000"/>
+            </a:avLst>
+          </a:prstGeom>
+          <a:solidFill>
+            <a:srgbClr val="8B3A2F"/>
+          </a:solidFill>
+          <a:ln/>
+        </p:spPr>
+      </p:sp>
+      <p:sp>
+        <p:nvSpPr>
+          <p:cNvPr id="10" name="Shape 7"/>
+          <p:cNvSpPr/>
+          <p:nvPr/>
+        </p:nvSpPr>
+        <p:spPr>
+          <a:xfrm>
+            <a:off x="3227832" y="1783080"/>
+            <a:ext cx="502920" cy="502920"/>
+          </a:xfrm>
+          <a:prstGeom prst="ellipse">
+            <a:avLst/>
+          </a:prstGeom>
+          <a:solidFill>
+            <a:srgbClr val="6B2A22"/>
+          </a:solidFill>
+          <a:ln/>
+        </p:spPr>
+      </p:sp>
+      <p:pic>
+        <p:nvPicPr>
+          <p:cNvPr id="11" name="Image 1" descr="preencoded.png">    </p:cNvPr>
+          <p:cNvPicPr>
+            <a:picLocks noChangeAspect="1"/>
+          </p:cNvPicPr>
+          <p:nvPr/>
+        </p:nvPicPr>
+        <p:blipFill>
+          <a:blip r:embed="rId2"/>
+          <a:stretch>
+            <a:fillRect/>
+          </a:stretch>
+        </p:blipFill>
+        <p:spPr>
+          <a:xfrm>
+            <a:off x="3340989" y="1896237"/>
+            <a:ext cx="276606" cy="276606"/>
+          </a:xfrm>
+          <a:prstGeom prst="rect">
+            <a:avLst/>
+          </a:prstGeom>
+        </p:spPr>
+      </p:pic>
+      <p:sp>
+        <p:nvSpPr>
+          <p:cNvPr id="12" name="Text 8"/>
+          <p:cNvSpPr txBox="1"/>
+          <p:nvPr/>
+        </p:nvSpPr>
+        <p:spPr>
+          <a:xfrm>
+            <a:off x="2606040" y="2423160"/>
+            <a:ext cx="1783080" cy="274320"/>
+          </a:xfrm>
+          <a:prstGeom prst="rect">
+            <a:avLst/>
+          </a:prstGeom>
+          <a:noFill/>
+          <a:ln/>
+        </p:spPr>
+        <p:txBody>
+          <a:bodyPr wrap="square" lIns="0" tIns="0" rIns="0" bIns="0" rtlCol="0" anchor="t"/>
+          <a:lstStyle/>
+          <a:p>
+            <a:pPr algn="ctr" indent="0" marL="0">
+              <a:buNone/>
+            </a:pPr>
+            <a:r>
+              <a:rPr lang="en-US" sz="1150" b="1" dirty="0">
+                <a:solidFill>
+                  <a:srgbClr val="FFFFFF"/>
+                </a:solidFill>
+                <a:latin typeface="Calibri" pitchFamily="34" charset="0"/>
+                <a:ea typeface="Calibri" pitchFamily="34" charset="-122"/>
+                <a:cs typeface="Calibri" pitchFamily="34" charset="-120"/>
+              </a:rPr>
+              <a:t>2 Not in dataset</a:t>
+            </a:r>
+            <a:endParaRPr lang="en-US" sz="1150" dirty="0"/>
+          </a:p>
+        </p:txBody>
+      </p:sp>
+      <p:sp>
+        <p:nvSpPr>
+          <p:cNvPr id="13" name="Text 9"/>
+          <p:cNvSpPr txBox="1"/>
+          <p:nvPr/>
+        </p:nvSpPr>
+        <p:spPr>
+          <a:xfrm>
+            <a:off x="2651760" y="2743200"/>
+            <a:ext cx="1691640" cy="731520"/>
+          </a:xfrm>
+          <a:prstGeom prst="rect">
+            <a:avLst/>
+          </a:prstGeom>
+          <a:noFill/>
+          <a:ln/>
+        </p:spPr>
+        <p:txBody>
+          <a:bodyPr wrap="square" lIns="0" tIns="0" rIns="0" bIns="0" rtlCol="0" anchor="t"/>
+          <a:lstStyle/>
+          <a:p>
+            <a:pPr algn="ctr" indent="0" marL="0">
+              <a:buNone/>
+            </a:pPr>
+            <a:r>
+              <a:rPr lang="en-US" sz="850" dirty="0">
+                <a:solidFill>
+                  <a:srgbClr val="E8C29C"/>
+                </a:solidFill>
+                <a:latin typeface="Calibri" pitchFamily="34" charset="0"/>
+                <a:ea typeface="Calibri" pitchFamily="34" charset="-122"/>
+                <a:cs typeface="Calibri" pitchFamily="34" charset="-120"/>
+              </a:rPr>
+              <a:t>Beef rendang, churros with chocolate sauce. Correct answer: no relevant recipe found.</a:t>
+            </a:r>
+            <a:endParaRPr lang="en-US" sz="850" dirty="0"/>
+          </a:p>
+        </p:txBody>
+      </p:sp>
+      <p:sp>
+        <p:nvSpPr>
+          <p:cNvPr id="14" name="Shape 10"/>
+          <p:cNvSpPr/>
+          <p:nvPr/>
+        </p:nvSpPr>
+        <p:spPr>
+          <a:xfrm>
+            <a:off x="4617720" y="1645920"/>
+            <a:ext cx="1965960" cy="1828800"/>
+          </a:xfrm>
+          <a:prstGeom prst="roundRect">
+            <a:avLst>
+              <a:gd name="adj" fmla="val 3000"/>
+            </a:avLst>
+          </a:prstGeom>
+          <a:solidFill>
+            <a:srgbClr val="8B3A2F"/>
+          </a:solidFill>
+          <a:ln/>
+        </p:spPr>
+      </p:sp>
+      <p:sp>
+        <p:nvSpPr>
+          <p:cNvPr id="15" name="Shape 11"/>
+          <p:cNvSpPr/>
+          <p:nvPr/>
+        </p:nvSpPr>
+        <p:spPr>
+          <a:xfrm>
+            <a:off x="5330952" y="1783080"/>
+            <a:ext cx="502920" cy="502920"/>
+          </a:xfrm>
+          <a:prstGeom prst="ellipse">
+            <a:avLst/>
+          </a:prstGeom>
+          <a:solidFill>
+            <a:srgbClr val="6B2A22"/>
+          </a:solidFill>
+          <a:ln/>
+        </p:spPr>
+      </p:sp>
+      <p:pic>
+        <p:nvPicPr>
+          <p:cNvPr id="16" name="Image 2" descr="preencoded.png">    </p:cNvPr>
+          <p:cNvPicPr>
+            <a:picLocks noChangeAspect="1"/>
+          </p:cNvPicPr>
+          <p:nvPr/>
+        </p:nvPicPr>
+        <p:blipFill>
+          <a:blip r:embed="rId3"/>
+          <a:stretch>
+            <a:fillRect/>
+          </a:stretch>
+        </p:blipFill>
+        <p:spPr>
+          <a:xfrm>
+            <a:off x="5444109" y="1896237"/>
+            <a:ext cx="276606" cy="276606"/>
+          </a:xfrm>
+          <a:prstGeom prst="rect">
+            <a:avLst/>
+          </a:prstGeom>
+        </p:spPr>
+      </p:pic>
+      <p:sp>
+        <p:nvSpPr>
+          <p:cNvPr id="17" name="Text 12"/>
+          <p:cNvSpPr txBox="1"/>
+          <p:nvPr/>
+        </p:nvSpPr>
+        <p:spPr>
+          <a:xfrm>
+            <a:off x="4709160" y="2423160"/>
+            <a:ext cx="1783080" cy="274320"/>
+          </a:xfrm>
+          <a:prstGeom prst="rect">
+            <a:avLst/>
+          </a:prstGeom>
+          <a:noFill/>
+          <a:ln/>
+        </p:spPr>
+        <p:txBody>
+          <a:bodyPr wrap="square" lIns="0" tIns="0" rIns="0" bIns="0" rtlCol="0" anchor="t"/>
+          <a:lstStyle/>
+          <a:p>
+            <a:pPr algn="ctr" indent="0" marL="0">
+              <a:buNone/>
+            </a:pPr>
+            <a:r>
+              <a:rPr lang="en-US" sz="1150" b="1" dirty="0">
+                <a:solidFill>
+                  <a:srgbClr val="FFFFFF"/>
+                </a:solidFill>
+                <a:latin typeface="Calibri" pitchFamily="34" charset="0"/>
+                <a:ea typeface="Calibri" pitchFamily="34" charset="-122"/>
+                <a:cs typeface="Calibri" pitchFamily="34" charset="-120"/>
+              </a:rPr>
+              <a:t>3 Ambiguous</a:t>
+            </a:r>
+            <a:endParaRPr lang="en-US" sz="1150" dirty="0"/>
+          </a:p>
+        </p:txBody>
+      </p:sp>
+      <p:sp>
+        <p:nvSpPr>
+          <p:cNvPr id="18" name="Text 13"/>
+          <p:cNvSpPr txBox="1"/>
+          <p:nvPr/>
+        </p:nvSpPr>
+        <p:spPr>
+          <a:xfrm>
+            <a:off x="4754880" y="2743200"/>
+            <a:ext cx="1691640" cy="731520"/>
+          </a:xfrm>
+          <a:prstGeom prst="rect">
+            <a:avLst/>
+          </a:prstGeom>
+          <a:noFill/>
+          <a:ln/>
+        </p:spPr>
+        <p:txBody>
+          <a:bodyPr wrap="square" lIns="0" tIns="0" rIns="0" bIns="0" rtlCol="0" anchor="t"/>
+          <a:lstStyle/>
+          <a:p>
+            <a:pPr algn="ctr" indent="0" marL="0">
+              <a:buNone/>
+            </a:pPr>
+            <a:r>
+              <a:rPr lang="en-US" sz="850" dirty="0">
+                <a:solidFill>
+                  <a:srgbClr val="E8C29C"/>
+                </a:solidFill>
+                <a:latin typeface="Calibri" pitchFamily="34" charset="0"/>
+                <a:ea typeface="Calibri" pitchFamily="34" charset="-122"/>
+                <a:cs typeface="Calibri" pitchFamily="34" charset="-120"/>
+              </a:rPr>
+              <a:t>Sushi egg roll, seafood carbonara, mango cheesecake. Family exists, exact dish does not.</a:t>
+            </a:r>
+            <a:endParaRPr lang="en-US" sz="850" dirty="0"/>
+          </a:p>
+        </p:txBody>
+      </p:sp>
+      <p:sp>
+        <p:nvSpPr>
+          <p:cNvPr id="19" name="Shape 14"/>
+          <p:cNvSpPr/>
+          <p:nvPr/>
+        </p:nvSpPr>
+        <p:spPr>
+          <a:xfrm>
+            <a:off x="6720840" y="1645920"/>
+            <a:ext cx="1965960" cy="1828800"/>
+          </a:xfrm>
+          <a:prstGeom prst="roundRect">
+            <a:avLst>
+              <a:gd name="adj" fmla="val 3000"/>
+            </a:avLst>
+          </a:prstGeom>
+          <a:solidFill>
+            <a:srgbClr val="8B3A2F"/>
+          </a:solidFill>
+          <a:ln/>
+        </p:spPr>
+      </p:sp>
+      <p:sp>
+        <p:nvSpPr>
+          <p:cNvPr id="20" name="Shape 15"/>
+          <p:cNvSpPr/>
+          <p:nvPr/>
+        </p:nvSpPr>
+        <p:spPr>
+          <a:xfrm>
+            <a:off x="7434072" y="1783080"/>
+            <a:ext cx="502920" cy="502920"/>
+          </a:xfrm>
+          <a:prstGeom prst="ellipse">
+            <a:avLst/>
+          </a:prstGeom>
+          <a:solidFill>
+            <a:srgbClr val="6B2A22"/>
+          </a:solidFill>
+          <a:ln/>
+        </p:spPr>
+      </p:sp>
+      <p:pic>
+        <p:nvPicPr>
+          <p:cNvPr id="21" name="Image 3" descr="preencoded.png">    </p:cNvPr>
+          <p:cNvPicPr>
+            <a:picLocks noChangeAspect="1"/>
+          </p:cNvPicPr>
+          <p:nvPr/>
+        </p:nvPicPr>
+        <p:blipFill>
+          <a:blip r:embed="rId4"/>
+          <a:stretch>
+            <a:fillRect/>
+          </a:stretch>
+        </p:blipFill>
+        <p:spPr>
+          <a:xfrm>
+            <a:off x="7547229" y="1896237"/>
+            <a:ext cx="276606" cy="276606"/>
+          </a:xfrm>
+          <a:prstGeom prst="rect">
+            <a:avLst/>
+          </a:prstGeom>
+        </p:spPr>
+      </p:pic>
+      <p:sp>
+        <p:nvSpPr>
+          <p:cNvPr id="22" name="Text 16"/>
+          <p:cNvSpPr txBox="1"/>
+          <p:nvPr/>
+        </p:nvSpPr>
+        <p:spPr>
+          <a:xfrm>
+            <a:off x="6812280" y="2423160"/>
+            <a:ext cx="1783080" cy="274320"/>
+          </a:xfrm>
+          <a:prstGeom prst="rect">
+            <a:avLst/>
+          </a:prstGeom>
+          <a:noFill/>
+          <a:ln/>
+        </p:spPr>
+        <p:txBody>
+          <a:bodyPr wrap="square" lIns="0" tIns="0" rIns="0" bIns="0" rtlCol="0" anchor="t"/>
+          <a:lstStyle/>
+          <a:p>
+            <a:pPr algn="ctr" indent="0" marL="0">
+              <a:buNone/>
+            </a:pPr>
+            <a:r>
+              <a:rPr lang="en-US" sz="1150" b="1" dirty="0">
+                <a:solidFill>
+                  <a:srgbClr val="FFFFFF"/>
+                </a:solidFill>
+                <a:latin typeface="Calibri" pitchFamily="34" charset="0"/>
+                <a:ea typeface="Calibri" pitchFamily="34" charset="-122"/>
+                <a:cs typeface="Calibri" pitchFamily="34" charset="-120"/>
+              </a:rPr>
+              <a:t>Result: 5 of 5 refused</a:t>
+            </a:r>
+            <a:endParaRPr lang="en-US" sz="1150" dirty="0"/>
+          </a:p>
+        </p:txBody>
+      </p:sp>
+      <p:sp>
+        <p:nvSpPr>
+          <p:cNvPr id="23" name="Text 17"/>
+          <p:cNvSpPr txBox="1"/>
+          <p:nvPr/>
+        </p:nvSpPr>
+        <p:spPr>
+          <a:xfrm>
+            <a:off x="6858000" y="2743200"/>
+            <a:ext cx="1691640" cy="731520"/>
+          </a:xfrm>
+          <a:prstGeom prst="rect">
+            <a:avLst/>
+          </a:prstGeom>
+          <a:noFill/>
+          <a:ln/>
+        </p:spPr>
+        <p:txBody>
+          <a:bodyPr wrap="square" lIns="0" tIns="0" rIns="0" bIns="0" rtlCol="0" anchor="t"/>
+          <a:lstStyle/>
+          <a:p>
+            <a:pPr algn="ctr" indent="0" marL="0">
+              <a:buNone/>
+            </a:pPr>
+            <a:r>
+              <a:rPr lang="en-US" sz="850" dirty="0">
+                <a:solidFill>
+                  <a:srgbClr val="E8C29C"/>
+                </a:solidFill>
+                <a:latin typeface="Calibri" pitchFamily="34" charset="0"/>
+                <a:ea typeface="Calibri" pitchFamily="34" charset="-122"/>
+                <a:cs typeface="Calibri" pitchFamily="34" charset="-120"/>
+              </a:rPr>
+              <a:t>All 5 answered “No relevant recipes found” and scored 5/5. No made-up recipes.</a:t>
+            </a:r>
+            <a:endParaRPr lang="en-US" sz="850" dirty="0"/>
+          </a:p>
+        </p:txBody>
+      </p:sp>
+      <p:sp>
+        <p:nvSpPr>
+          <p:cNvPr id="24" name="Text 18"/>
+          <p:cNvSpPr txBox="1"/>
+          <p:nvPr/>
+        </p:nvSpPr>
+        <p:spPr>
+          <a:xfrm>
+            <a:off x="457200" y="3931920"/>
+            <a:ext cx="8229600" cy="457200"/>
+          </a:xfrm>
+          <a:prstGeom prst="rect">
+            <a:avLst/>
+          </a:prstGeom>
+          <a:noFill/>
+          <a:ln/>
+        </p:spPr>
+        <p:txBody>
+          <a:bodyPr wrap="square" lIns="0" tIns="0" rIns="0" bIns="0" rtlCol="0" anchor="t"/>
+          <a:lstStyle/>
+          <a:p>
+            <a:pPr indent="0" marL="0">
+              <a:buNone/>
+            </a:pPr>
+            <a:r>
+              <a:rPr lang="en-US" sz="1200" i="1" dirty="0">
+                <a:solidFill>
+                  <a:srgbClr val="6B5E57"/>
+                </a:solidFill>
+                <a:latin typeface="Calibri" pitchFamily="34" charset="0"/>
+                <a:ea typeface="Calibri" pitchFamily="34" charset="-122"/>
+                <a:cs typeface="Calibri" pitchFamily="34" charset="-120"/>
+              </a:rPr>
+              <a:t>The model refused seafood carbonara, sushi egg roll and mango cheesecake, even though related recipes exist in the corpus.</a:t>
+            </a:r>
+            <a:endParaRPr lang="en-US" sz="1200" dirty="0"/>
+          </a:p>
+        </p:txBody>
+      </p:sp>
+    </p:spTree>
+  </p:cSld>
+  <p:clrMapOvr>
+    <a:masterClrMapping/>
+  </p:clrMapOvr>
+</p:sld>
+</file>
+
 <file path=ppt/slides/slide2.xml><?xml version="1.0" encoding="utf-8"?>
 <p:sld xmlns:a="http://schemas.openxmlformats.org/drawingml/2006/main" xmlns:r="http://schemas.openxmlformats.org/officeDocument/2006/relationships" xmlns:p="http://schemas.openxmlformats.org/presentationml/2006/main">
   <p:cSld name="Slide 2">
@@ -6093,7 +6819,7 @@
                 <a:ea typeface="Calibri" pitchFamily="34" charset="-122"/>
                 <a:cs typeface="Calibri" pitchFamily="34" charset="-120"/>
               </a:rPr>
-              <a:t>Key methodology choice: each test case is run once, and the answers are consistent. Truncation was also removed so no information is lost.</a:t>
+              <a:t>Key methodology choice: each test case is run once, and the answers are consistent. Truncation was also removed. A correct “no match” answer scores 5/5.</a:t>
             </a:r>
             <a:endParaRPr lang="en-US" sz="1200" dirty="0"/>
           </a:p>
@@ -6203,7 +6929,7 @@
                 <a:ea typeface="Calibri" pitchFamily="34" charset="-122"/>
                 <a:cs typeface="Calibri" pitchFamily="34" charset="-120"/>
               </a:rPr>
-              <a:t>Averaged across 4 baseline runs, then re-validated after fixes</a:t>
+              <a:t>30-case run vs earlier 4-run baseline. Completeness and Retrieval Hit shown as rate × 5.</a:t>
             </a:r>
             <a:endParaRPr lang="en-US" sz="1100" dirty="0"/>
           </a:p>
@@ -6280,7 +7006,7 @@
                 <a:ea typeface="Georgia" pitchFamily="34" charset="-122"/>
                 <a:cs typeface="Georgia" pitchFamily="34" charset="-120"/>
               </a:rPr>
-              <a:t>4.6/5</a:t>
+              <a:t>4.93/5</a:t>
             </a:r>
             <a:endParaRPr lang="en-US" sz="2000" dirty="0"/>
           </a:p>
@@ -6319,7 +7045,7 @@
                 <a:ea typeface="Calibri" pitchFamily="34" charset="-122"/>
                 <a:cs typeface="Calibri" pitchFamily="34" charset="-120"/>
               </a:rPr>
-              <a:t>Avg faithfulness (23 of 25 cases scored 5)</a:t>
+              <a:t>Avg faithfulness (28 of 30 cases scored 5)</a:t>
             </a:r>
             <a:endParaRPr lang="en-US" sz="850" dirty="0"/>
           </a:p>
@@ -6380,7 +7106,7 @@
                 <a:ea typeface="Georgia" pitchFamily="34" charset="-122"/>
                 <a:cs typeface="Georgia" pitchFamily="34" charset="-120"/>
               </a:rPr>
-              <a:t>99.2%</a:t>
+              <a:t>99.1%</a:t>
             </a:r>
             <a:endParaRPr lang="en-US" sz="2000" dirty="0"/>
           </a:p>
@@ -6480,7 +7206,7 @@
                 <a:ea typeface="Georgia" pitchFamily="34" charset="-122"/>
                 <a:cs typeface="Georgia" pitchFamily="34" charset="-120"/>
               </a:rPr>
-              <a:t>92%</a:t>
+              <a:t>93%</a:t>
             </a:r>
             <a:endParaRPr lang="en-US" sz="2000" dirty="0"/>
           </a:p>
@@ -6619,7 +7345,7 @@
                 <a:ea typeface="Calibri" pitchFamily="34" charset="-122"/>
                 <a:cs typeface="Calibri" pitchFamily="34" charset="-120"/>
               </a:rPr>
-              <a:t>Genuine model errors (2 quota 429s)</a:t>
+              <a:t>Model errors (0 of 30 cases)</a:t>
             </a:r>
             <a:endParaRPr lang="en-US" sz="850" dirty="0"/>
           </a:p>

</xml_diff>

<commit_message>
updated lingua and removed langdetect
</commit_message>
<xml_diff>
--- a/ppt/craveitsearchitcookit_presentation.pptx
+++ b/ppt/craveitsearchitcookit_presentation.pptx
@@ -3095,7 +3095,7 @@
                 <a:ea typeface="Calibri" pitchFamily="34" charset="-122"/>
                 <a:cs typeface="Calibri" pitchFamily="34" charset="-120"/>
               </a:rPr>
-              <a:t>Auto-detects &amp; translates 20+ languages before retrieval</a:t>
+              <a:t>Auto-detects (Lingua) &amp; translates 70+ languages before retrieval</a:t>
             </a:r>
             <a:endParaRPr lang="en-US" sz="1050" dirty="0"/>
           </a:p>
@@ -4083,7 +4083,7 @@
                 <a:ea typeface="Calibri" pitchFamily="34" charset="-122"/>
                 <a:cs typeface="Calibri" pitchFamily="34" charset="-120"/>
               </a:rPr>
-              <a:t>deep-translator</a:t>
+              <a:t>Lingua + deep-translator</a:t>
             </a:r>
             <a:endParaRPr lang="en-US" sz="900" dirty="0"/>
           </a:p>
@@ -5911,7 +5911,7 @@
                 <a:ea typeface="Calibri" pitchFamily="34" charset="-122"/>
                 <a:cs typeface="Calibri" pitchFamily="34" charset="-120"/>
               </a:rPr>
-              <a:t>deep-translator + langdetect</a:t>
+              <a:t>deep-translator + Lingua</a:t>
             </a:r>
             <a:endParaRPr lang="en-US" sz="1100" dirty="0"/>
           </a:p>
@@ -5950,7 +5950,7 @@
                 <a:ea typeface="Calibri" pitchFamily="34" charset="-122"/>
                 <a:cs typeface="Calibri" pitchFamily="34" charset="-120"/>
               </a:rPr>
-              <a:t>Any-language query support</a:t>
+              <a:t>Language detection + translation</a:t>
             </a:r>
             <a:endParaRPr lang="en-US" sz="850" dirty="0"/>
           </a:p>

</xml_diff>